<commit_message>
Added tests for filter number selector.
</commit_message>
<xml_diff>
--- a/HE_SATT_Documentation.pptx
+++ b/HE_SATT_Documentation.pptx
@@ -105,6 +105,11 @@
       </a:defRPr>
     </a:lvl9pPr>
   </p:defaultTextStyle>
+  <p:extLst>
+    <p:ext uri="{EFAFB233-063F-42B5-8137-9DF3F51BA10A}">
+      <p15:sldGuideLst xmlns:p15="http://schemas.microsoft.com/office/powerpoint/2012/main"/>
+    </p:ext>
+  </p:extLst>
 </p:presentation>
 </file>
 
@@ -255,7 +260,7 @@
           <a:p>
             <a:fld id="{61381E2E-4624-477F-882A-4323BE84FF14}" type="datetimeFigureOut">
               <a:rPr lang="en-US" smtClean="0"/>
-              <a:t>8/21/2025</a:t>
+              <a:t>8/28/2025</a:t>
             </a:fld>
             <a:endParaRPr lang="en-US"/>
           </a:p>
@@ -453,7 +458,7 @@
           <a:p>
             <a:fld id="{61381E2E-4624-477F-882A-4323BE84FF14}" type="datetimeFigureOut">
               <a:rPr lang="en-US" smtClean="0"/>
-              <a:t>8/21/2025</a:t>
+              <a:t>8/28/2025</a:t>
             </a:fld>
             <a:endParaRPr lang="en-US"/>
           </a:p>
@@ -661,7 +666,7 @@
           <a:p>
             <a:fld id="{61381E2E-4624-477F-882A-4323BE84FF14}" type="datetimeFigureOut">
               <a:rPr lang="en-US" smtClean="0"/>
-              <a:t>8/21/2025</a:t>
+              <a:t>8/28/2025</a:t>
             </a:fld>
             <a:endParaRPr lang="en-US"/>
           </a:p>
@@ -859,7 +864,7 @@
           <a:p>
             <a:fld id="{61381E2E-4624-477F-882A-4323BE84FF14}" type="datetimeFigureOut">
               <a:rPr lang="en-US" smtClean="0"/>
-              <a:t>8/21/2025</a:t>
+              <a:t>8/28/2025</a:t>
             </a:fld>
             <a:endParaRPr lang="en-US"/>
           </a:p>
@@ -1134,7 +1139,7 @@
           <a:p>
             <a:fld id="{61381E2E-4624-477F-882A-4323BE84FF14}" type="datetimeFigureOut">
               <a:rPr lang="en-US" smtClean="0"/>
-              <a:t>8/21/2025</a:t>
+              <a:t>8/28/2025</a:t>
             </a:fld>
             <a:endParaRPr lang="en-US"/>
           </a:p>
@@ -1399,7 +1404,7 @@
           <a:p>
             <a:fld id="{61381E2E-4624-477F-882A-4323BE84FF14}" type="datetimeFigureOut">
               <a:rPr lang="en-US" smtClean="0"/>
-              <a:t>8/21/2025</a:t>
+              <a:t>8/28/2025</a:t>
             </a:fld>
             <a:endParaRPr lang="en-US"/>
           </a:p>
@@ -1811,7 +1816,7 @@
           <a:p>
             <a:fld id="{61381E2E-4624-477F-882A-4323BE84FF14}" type="datetimeFigureOut">
               <a:rPr lang="en-US" smtClean="0"/>
-              <a:t>8/21/2025</a:t>
+              <a:t>8/28/2025</a:t>
             </a:fld>
             <a:endParaRPr lang="en-US"/>
           </a:p>
@@ -1952,7 +1957,7 @@
           <a:p>
             <a:fld id="{61381E2E-4624-477F-882A-4323BE84FF14}" type="datetimeFigureOut">
               <a:rPr lang="en-US" smtClean="0"/>
-              <a:t>8/21/2025</a:t>
+              <a:t>8/28/2025</a:t>
             </a:fld>
             <a:endParaRPr lang="en-US"/>
           </a:p>
@@ -2065,7 +2070,7 @@
           <a:p>
             <a:fld id="{61381E2E-4624-477F-882A-4323BE84FF14}" type="datetimeFigureOut">
               <a:rPr lang="en-US" smtClean="0"/>
-              <a:t>8/21/2025</a:t>
+              <a:t>8/28/2025</a:t>
             </a:fld>
             <a:endParaRPr lang="en-US"/>
           </a:p>
@@ -2376,7 +2381,7 @@
           <a:p>
             <a:fld id="{61381E2E-4624-477F-882A-4323BE84FF14}" type="datetimeFigureOut">
               <a:rPr lang="en-US" smtClean="0"/>
-              <a:t>8/21/2025</a:t>
+              <a:t>8/28/2025</a:t>
             </a:fld>
             <a:endParaRPr lang="en-US"/>
           </a:p>
@@ -2664,7 +2669,7 @@
           <a:p>
             <a:fld id="{61381E2E-4624-477F-882A-4323BE84FF14}" type="datetimeFigureOut">
               <a:rPr lang="en-US" smtClean="0"/>
-              <a:t>8/21/2025</a:t>
+              <a:t>8/28/2025</a:t>
             </a:fld>
             <a:endParaRPr lang="en-US"/>
           </a:p>
@@ -2905,7 +2910,7 @@
           <a:p>
             <a:fld id="{61381E2E-4624-477F-882A-4323BE84FF14}" type="datetimeFigureOut">
               <a:rPr lang="en-US" smtClean="0"/>
-              <a:t>8/21/2025</a:t>
+              <a:t>8/28/2025</a:t>
             </a:fld>
             <a:endParaRPr lang="en-US"/>
           </a:p>
@@ -4547,7 +4552,7 @@
         </p:blipFill>
         <p:spPr>
           <a:xfrm>
-            <a:off x="1190029" y="1363661"/>
+            <a:off x="1205917" y="806396"/>
             <a:ext cx="1195907" cy="4869809"/>
           </a:xfrm>
           <a:prstGeom prst="rect">
@@ -4578,7 +4583,7 @@
         </p:blipFill>
         <p:spPr>
           <a:xfrm>
-            <a:off x="5531224" y="857154"/>
+            <a:off x="5561145" y="-1804490"/>
             <a:ext cx="1624820" cy="4869809"/>
           </a:xfrm>
           <a:prstGeom prst="rect">
@@ -4609,7 +4614,7 @@
         </p:blipFill>
         <p:spPr>
           <a:xfrm>
-            <a:off x="3409545" y="346495"/>
+            <a:off x="3409543" y="111071"/>
             <a:ext cx="1195907" cy="4869809"/>
           </a:xfrm>
           <a:prstGeom prst="rect">
@@ -4640,7 +4645,7 @@
         </p:blipFill>
         <p:spPr>
           <a:xfrm>
-            <a:off x="9735671" y="-639952"/>
+            <a:off x="9697919" y="-1766126"/>
             <a:ext cx="1624820" cy="4869809"/>
           </a:xfrm>
           <a:prstGeom prst="rect">
@@ -4928,6 +4933,233 @@
             <a:r>
               <a:rPr lang="en-US" dirty="0"/>
               <a:t>Total attenuation = 1 - Total transmission </a:t>
+            </a:r>
+          </a:p>
+        </p:txBody>
+      </p:sp>
+      <p:sp>
+        <p:nvSpPr>
+          <p:cNvPr id="18" name="TextBox 17">
+            <a:extLst>
+              <a:ext uri="{FF2B5EF4-FFF2-40B4-BE49-F238E27FC236}">
+                <a16:creationId xmlns:a16="http://schemas.microsoft.com/office/drawing/2014/main" id="{66778469-4AB4-B1F8-39DC-CE70F0FF8B43}"/>
+              </a:ext>
+            </a:extLst>
+          </p:cNvPr>
+          <p:cNvSpPr txBox="1"/>
+          <p:nvPr/>
+        </p:nvSpPr>
+        <p:spPr>
+          <a:xfrm>
+            <a:off x="0" y="19644"/>
+            <a:ext cx="2411835" cy="369332"/>
+          </a:xfrm>
+          <a:prstGeom prst="rect">
+            <a:avLst/>
+          </a:prstGeom>
+          <a:noFill/>
+        </p:spPr>
+        <p:txBody>
+          <a:bodyPr wrap="square" rtlCol="0">
+            <a:spAutoFit/>
+          </a:bodyPr>
+          <a:lstStyle/>
+          <a:p>
+            <a:r>
+              <a:rPr lang="en-US" dirty="0"/>
+              <a:t>Desired Transmission</a:t>
+            </a:r>
+          </a:p>
+        </p:txBody>
+      </p:sp>
+      <p:cxnSp>
+        <p:nvCxnSpPr>
+          <p:cNvPr id="20" name="Straight Arrow Connector 19">
+            <a:extLst>
+              <a:ext uri="{FF2B5EF4-FFF2-40B4-BE49-F238E27FC236}">
+                <a16:creationId xmlns:a16="http://schemas.microsoft.com/office/drawing/2014/main" id="{8E77421B-24CB-FA36-E0B7-5129134F6B89}"/>
+              </a:ext>
+            </a:extLst>
+          </p:cNvPr>
+          <p:cNvCxnSpPr>
+            <a:stCxn id="18" idx="3"/>
+          </p:cNvCxnSpPr>
+          <p:nvPr/>
+        </p:nvCxnSpPr>
+        <p:spPr>
+          <a:xfrm>
+            <a:off x="2411835" y="204310"/>
+            <a:ext cx="2336334" cy="9609"/>
+          </a:xfrm>
+          <a:prstGeom prst="straightConnector1">
+            <a:avLst/>
+          </a:prstGeom>
+          <a:ln>
+            <a:tailEnd type="triangle"/>
+          </a:ln>
+        </p:spPr>
+        <p:style>
+          <a:lnRef idx="2">
+            <a:schemeClr val="accent1"/>
+          </a:lnRef>
+          <a:fillRef idx="0">
+            <a:schemeClr val="accent1"/>
+          </a:fillRef>
+          <a:effectRef idx="1">
+            <a:schemeClr val="accent1"/>
+          </a:effectRef>
+          <a:fontRef idx="minor">
+            <a:schemeClr val="tx1"/>
+          </a:fontRef>
+        </p:style>
+      </p:cxnSp>
+      <p:sp>
+        <p:nvSpPr>
+          <p:cNvPr id="21" name="Rectangle 20">
+            <a:extLst>
+              <a:ext uri="{FF2B5EF4-FFF2-40B4-BE49-F238E27FC236}">
+                <a16:creationId xmlns:a16="http://schemas.microsoft.com/office/drawing/2014/main" id="{FDABEE18-610B-C97A-DDB0-30F0BF1860BB}"/>
+              </a:ext>
+            </a:extLst>
+          </p:cNvPr>
+          <p:cNvSpPr/>
+          <p:nvPr/>
+        </p:nvSpPr>
+        <p:spPr>
+          <a:xfrm>
+            <a:off x="4748169" y="62917"/>
+            <a:ext cx="1451295" cy="529168"/>
+          </a:xfrm>
+          <a:prstGeom prst="rect">
+            <a:avLst/>
+          </a:prstGeom>
+        </p:spPr>
+        <p:style>
+          <a:lnRef idx="2">
+            <a:schemeClr val="accent1">
+              <a:shade val="15000"/>
+            </a:schemeClr>
+          </a:lnRef>
+          <a:fillRef idx="1">
+            <a:schemeClr val="accent1"/>
+          </a:fillRef>
+          <a:effectRef idx="0">
+            <a:schemeClr val="accent1"/>
+          </a:effectRef>
+          <a:fontRef idx="minor">
+            <a:schemeClr val="lt1"/>
+          </a:fontRef>
+        </p:style>
+        <p:txBody>
+          <a:bodyPr rtlCol="0" anchor="ctr"/>
+          <a:lstStyle/>
+          <a:p>
+            <a:pPr algn="ctr"/>
+            <a:endParaRPr lang="en-US"/>
+          </a:p>
+        </p:txBody>
+      </p:sp>
+      <p:sp>
+        <p:nvSpPr>
+          <p:cNvPr id="2" name="TextBox 1">
+            <a:extLst>
+              <a:ext uri="{FF2B5EF4-FFF2-40B4-BE49-F238E27FC236}">
+                <a16:creationId xmlns:a16="http://schemas.microsoft.com/office/drawing/2014/main" id="{A76C1BC2-897E-FD28-83B9-99AF9F38A728}"/>
+              </a:ext>
+            </a:extLst>
+          </p:cNvPr>
+          <p:cNvSpPr txBox="1"/>
+          <p:nvPr/>
+        </p:nvSpPr>
+        <p:spPr>
+          <a:xfrm>
+            <a:off x="633369" y="2986481"/>
+            <a:ext cx="429829" cy="369332"/>
+          </a:xfrm>
+          <a:prstGeom prst="rect">
+            <a:avLst/>
+          </a:prstGeom>
+          <a:noFill/>
+        </p:spPr>
+        <p:txBody>
+          <a:bodyPr wrap="square" rtlCol="0">
+            <a:spAutoFit/>
+          </a:bodyPr>
+          <a:lstStyle/>
+          <a:p>
+            <a:r>
+              <a:rPr lang="en-US" dirty="0"/>
+              <a:t>25</a:t>
+            </a:r>
+          </a:p>
+        </p:txBody>
+      </p:sp>
+      <p:sp>
+        <p:nvSpPr>
+          <p:cNvPr id="3" name="TextBox 2">
+            <a:extLst>
+              <a:ext uri="{FF2B5EF4-FFF2-40B4-BE49-F238E27FC236}">
+                <a16:creationId xmlns:a16="http://schemas.microsoft.com/office/drawing/2014/main" id="{037862B8-754B-3FF6-005B-812922A83C76}"/>
+              </a:ext>
+            </a:extLst>
+          </p:cNvPr>
+          <p:cNvSpPr txBox="1"/>
+          <p:nvPr/>
+        </p:nvSpPr>
+        <p:spPr>
+          <a:xfrm>
+            <a:off x="2876495" y="2929567"/>
+            <a:ext cx="429829" cy="369332"/>
+          </a:xfrm>
+          <a:prstGeom prst="rect">
+            <a:avLst/>
+          </a:prstGeom>
+          <a:noFill/>
+        </p:spPr>
+        <p:txBody>
+          <a:bodyPr wrap="square" rtlCol="0">
+            <a:spAutoFit/>
+          </a:bodyPr>
+          <a:lstStyle/>
+          <a:p>
+            <a:r>
+              <a:rPr lang="en-US" dirty="0"/>
+              <a:t>50</a:t>
+            </a:r>
+          </a:p>
+        </p:txBody>
+      </p:sp>
+      <p:sp>
+        <p:nvSpPr>
+          <p:cNvPr id="7" name="TextBox 6">
+            <a:extLst>
+              <a:ext uri="{FF2B5EF4-FFF2-40B4-BE49-F238E27FC236}">
+                <a16:creationId xmlns:a16="http://schemas.microsoft.com/office/drawing/2014/main" id="{FFBD3DB4-1CA1-FA66-8973-0B364E5DB3AE}"/>
+              </a:ext>
+            </a:extLst>
+          </p:cNvPr>
+          <p:cNvSpPr txBox="1"/>
+          <p:nvPr/>
+        </p:nvSpPr>
+        <p:spPr>
+          <a:xfrm>
+            <a:off x="6158640" y="4321967"/>
+            <a:ext cx="429829" cy="369332"/>
+          </a:xfrm>
+          <a:prstGeom prst="rect">
+            <a:avLst/>
+          </a:prstGeom>
+          <a:noFill/>
+        </p:spPr>
+        <p:txBody>
+          <a:bodyPr wrap="square" rtlCol="0">
+            <a:spAutoFit/>
+          </a:bodyPr>
+          <a:lstStyle/>
+          <a:p>
+            <a:r>
+              <a:rPr lang="en-US" dirty="0"/>
+              <a:t>75</a:t>
             </a:r>
           </a:p>
         </p:txBody>

</xml_diff>

<commit_message>
Started implementing filter number selecting. Left off on figuring out how to visit every combination and check which one if the best for the selected rounding mode.
</commit_message>
<xml_diff>
--- a/HE_SATT_Documentation.pptx
+++ b/HE_SATT_Documentation.pptx
@@ -4552,7 +4552,7 @@
         </p:blipFill>
         <p:spPr>
           <a:xfrm>
-            <a:off x="1205917" y="806396"/>
+            <a:off x="1236935" y="2256394"/>
             <a:ext cx="1195907" cy="4869809"/>
           </a:xfrm>
           <a:prstGeom prst="rect">
@@ -4583,7 +4583,7 @@
         </p:blipFill>
         <p:spPr>
           <a:xfrm>
-            <a:off x="5561145" y="-1804490"/>
+            <a:off x="5561144" y="-1513996"/>
             <a:ext cx="1624820" cy="4869809"/>
           </a:xfrm>
           <a:prstGeom prst="rect">
@@ -4614,7 +4614,7 @@
         </p:blipFill>
         <p:spPr>
           <a:xfrm>
-            <a:off x="3409543" y="111071"/>
+            <a:off x="3409543" y="2016926"/>
             <a:ext cx="1195907" cy="4869809"/>
           </a:xfrm>
           <a:prstGeom prst="rect">

</xml_diff>